<commit_message>
feat(scenario2): add SDC workload (GreenGrid) with SaaS, demo and screenshots
- code the GreenGrid Score SaaS prerequisite (Express, /health + /score, x-api-key)
- add Fabric Extensibility Toolkit workload kit under src/workloadsdc (manifest, app, services, seed, spec)
- runnable demo: audit harness + 2 graphical screens (scorecard + site detail), real-data screenshots
- rename ISV -> SDC everywhere (docs, README, motion-brief, overview, deck slide regenerated)
- add SDC solution/setup/workbook docs; fill README SDC track with functional summary + 2 captures

Co-authored-by: Copilot <223556219+Copilot@users.noreply.github.com>
</commit_message>
<xml_diff>
--- a/deck/Motion-Fabric-Apps.pptx
+++ b/deck/Motion-Fabric-Apps.pptx
@@ -1619,7 +1619,7 @@
                 <a:ea typeface="Segoe UI Semibold" pitchFamily="34" charset="-122"/>
                 <a:cs typeface="Segoe UI Semibold" pitchFamily="34" charset="-120"/>
               </a:rPr>
-              <a:t>ISV / SDC</a:t>
+              <a:t>SDC</a:t>
             </a:r>
             <a:endParaRPr lang="en-US" sz="1200" dirty="0"/>
           </a:p>
@@ -1739,7 +1739,7 @@
                 <a:ea typeface="Segoe UI" pitchFamily="34" charset="-122"/>
                 <a:cs typeface="Segoe UI" pitchFamily="34" charset="-120"/>
               </a:rPr>
-              <a:t>— ISV </a:t>
+              <a:t>— SDC </a:t>
             </a:r>
             <a:pPr indent="0" marL="0">
               <a:buNone/>
@@ -1886,7 +1886,7 @@
                 <a:ea typeface="Segoe UI" pitchFamily="34" charset="-122"/>
                 <a:cs typeface="Segoe UI" pitchFamily="34" charset="-120"/>
               </a:rPr>
-              <a:t>Number of workloads per ISV</a:t>
+              <a:t>Number of workloads per SDC</a:t>
             </a:r>
             <a:endParaRPr lang="en-US" sz="1250" dirty="0"/>
           </a:p>
@@ -1950,7 +1950,7 @@
                 <a:ea typeface="Segoe UI" pitchFamily="34" charset="-122"/>
                 <a:cs typeface="Segoe UI" pitchFamily="34" charset="-120"/>
               </a:rPr>
-              <a:t>Vision: Adoption – one workload per ISV</a:t>
+              <a:t>Vision: Adoption – one workload per SDC</a:t>
             </a:r>
             <a:endParaRPr lang="en-US" sz="1100" dirty="0"/>
           </a:p>
@@ -2509,7 +2509,7 @@
                 <a:ea typeface="Segoe UI" pitchFamily="34" charset="-122"/>
                 <a:cs typeface="Segoe UI" pitchFamily="34" charset="-120"/>
               </a:rPr>
-              <a:t>ISV + Advisory → ONE Microsoft program</a:t>
+              <a:t>SDC + Advisory → ONE Microsoft program</a:t>
             </a:r>
             <a:endParaRPr lang="en-US" sz="1200" dirty="0"/>
           </a:p>

</xml_diff>